<commit_message>
Update PowerPoint for song #199 in FUBC - Українські
</commit_message>
<xml_diff>
--- a/fubc-ua/199-Радійте щиро (Пісні Спасенних №197).pptx
+++ b/fubc-ua/199-Радійте щиро (Пісні Спасенних №197).pptx
@@ -1825,7 +1825,7 @@
         </p:nvSpPr>
         <p:spPr>
           <a:xfrm>
-            <a:off x="2907005" y="2755392"/>
+            <a:off x="3006065" y="2755392"/>
             <a:ext cx="0" cy="2971800"/>
           </a:xfrm>
           <a:prstGeom prst="line">
@@ -1848,7 +1848,7 @@
         </p:nvSpPr>
         <p:spPr>
           <a:xfrm>
-            <a:off x="9291091" y="2755392"/>
+            <a:off x="9192031" y="2755392"/>
             <a:ext cx="0" cy="2971800"/>
           </a:xfrm>
           <a:prstGeom prst="line">
@@ -1871,8 +1871,8 @@
         </p:nvSpPr>
         <p:spPr>
           <a:xfrm>
-            <a:off x="9423171" y="4010152"/>
-            <a:ext cx="792480" cy="462280"/>
+            <a:off x="9291091" y="3921252"/>
+            <a:ext cx="1097280" cy="640080"/>
           </a:xfrm>
           <a:prstGeom prst="rect">
             <a:avLst/>
@@ -1888,9 +1888,9 @@
               <a:buNone/>
             </a:pPr>
             <a:r>
-              <a:rPr lang="en-US" sz="2600" b="1" dirty="0">
-                <a:solidFill>
-                  <a:srgbClr val="8A8A8A"/>
+              <a:rPr lang="en-US" sz="3600" b="1" dirty="0">
+                <a:solidFill>
+                  <a:srgbClr val="BBBBBB"/>
                 </a:solidFill>
                 <a:latin typeface="Arial" pitchFamily="34" charset="0"/>
                 <a:ea typeface="Arial" pitchFamily="34" charset="-122"/>
@@ -1898,7 +1898,7 @@
               </a:rPr>
               <a:t>×2</a:t>
             </a:r>
-            <a:endParaRPr lang="en-US" sz="2600" dirty="0"/>
+            <a:endParaRPr lang="en-US" sz="3600" dirty="0"/>
           </a:p>
         </p:txBody>
       </p:sp>
@@ -2104,7 +2104,7 @@
         </p:nvSpPr>
         <p:spPr>
           <a:xfrm>
-            <a:off x="2502840" y="3151632"/>
+            <a:off x="2601900" y="3151632"/>
             <a:ext cx="0" cy="2971800"/>
           </a:xfrm>
           <a:prstGeom prst="line">
@@ -2127,7 +2127,7 @@
         </p:nvSpPr>
         <p:spPr>
           <a:xfrm>
-            <a:off x="9695256" y="3151632"/>
+            <a:off x="9596196" y="3151632"/>
             <a:ext cx="0" cy="2971800"/>
           </a:xfrm>
           <a:prstGeom prst="line">
@@ -2150,8 +2150,8 @@
         </p:nvSpPr>
         <p:spPr>
           <a:xfrm>
-            <a:off x="9827336" y="4406392"/>
-            <a:ext cx="792480" cy="462280"/>
+            <a:off x="9695256" y="4317492"/>
+            <a:ext cx="1097280" cy="640080"/>
           </a:xfrm>
           <a:prstGeom prst="rect">
             <a:avLst/>
@@ -2167,9 +2167,9 @@
               <a:buNone/>
             </a:pPr>
             <a:r>
-              <a:rPr lang="en-US" sz="2600" b="1" dirty="0">
-                <a:solidFill>
-                  <a:srgbClr val="8A8A8A"/>
+              <a:rPr lang="en-US" sz="3600" b="1" dirty="0">
+                <a:solidFill>
+                  <a:srgbClr val="BBBBBB"/>
                 </a:solidFill>
                 <a:latin typeface="Arial" pitchFamily="34" charset="0"/>
                 <a:ea typeface="Arial" pitchFamily="34" charset="-122"/>
@@ -2177,7 +2177,7 @@
               </a:rPr>
               <a:t>×2</a:t>
             </a:r>
-            <a:endParaRPr lang="en-US" sz="2600" dirty="0"/>
+            <a:endParaRPr lang="en-US" sz="3600" dirty="0"/>
           </a:p>
         </p:txBody>
       </p:sp>
@@ -2383,7 +2383,7 @@
         </p:nvSpPr>
         <p:spPr>
           <a:xfrm>
-            <a:off x="2403450" y="3151632"/>
+            <a:off x="2502510" y="3151632"/>
             <a:ext cx="0" cy="2971800"/>
           </a:xfrm>
           <a:prstGeom prst="line">
@@ -2406,7 +2406,7 @@
         </p:nvSpPr>
         <p:spPr>
           <a:xfrm>
-            <a:off x="9794646" y="3151632"/>
+            <a:off x="9695586" y="3151632"/>
             <a:ext cx="0" cy="2971800"/>
           </a:xfrm>
           <a:prstGeom prst="line">
@@ -2429,8 +2429,8 @@
         </p:nvSpPr>
         <p:spPr>
           <a:xfrm>
-            <a:off x="9926726" y="4406392"/>
-            <a:ext cx="792480" cy="462280"/>
+            <a:off x="9794646" y="4317492"/>
+            <a:ext cx="1097280" cy="640080"/>
           </a:xfrm>
           <a:prstGeom prst="rect">
             <a:avLst/>
@@ -2446,9 +2446,9 @@
               <a:buNone/>
             </a:pPr>
             <a:r>
-              <a:rPr lang="en-US" sz="2600" b="1" dirty="0">
-                <a:solidFill>
-                  <a:srgbClr val="8A8A8A"/>
+              <a:rPr lang="en-US" sz="3600" b="1" dirty="0">
+                <a:solidFill>
+                  <a:srgbClr val="BBBBBB"/>
                 </a:solidFill>
                 <a:latin typeface="Arial" pitchFamily="34" charset="0"/>
                 <a:ea typeface="Arial" pitchFamily="34" charset="-122"/>
@@ -2456,7 +2456,7 @@
               </a:rPr>
               <a:t>×2</a:t>
             </a:r>
-            <a:endParaRPr lang="en-US" sz="2600" dirty="0"/>
+            <a:endParaRPr lang="en-US" sz="3600" dirty="0"/>
           </a:p>
         </p:txBody>
       </p:sp>
@@ -2662,7 +2662,7 @@
         </p:nvSpPr>
         <p:spPr>
           <a:xfrm>
-            <a:off x="2888183" y="3151632"/>
+            <a:off x="2987243" y="3151632"/>
             <a:ext cx="0" cy="2971800"/>
           </a:xfrm>
           <a:prstGeom prst="line">
@@ -2685,7 +2685,7 @@
         </p:nvSpPr>
         <p:spPr>
           <a:xfrm>
-            <a:off x="9309913" y="3151632"/>
+            <a:off x="9210853" y="3151632"/>
             <a:ext cx="0" cy="2971800"/>
           </a:xfrm>
           <a:prstGeom prst="line">
@@ -2708,8 +2708,8 @@
         </p:nvSpPr>
         <p:spPr>
           <a:xfrm>
-            <a:off x="9441993" y="4406392"/>
-            <a:ext cx="792480" cy="462280"/>
+            <a:off x="9309913" y="4317492"/>
+            <a:ext cx="1097280" cy="640080"/>
           </a:xfrm>
           <a:prstGeom prst="rect">
             <a:avLst/>
@@ -2725,9 +2725,9 @@
               <a:buNone/>
             </a:pPr>
             <a:r>
-              <a:rPr lang="en-US" sz="2600" b="1" dirty="0">
-                <a:solidFill>
-                  <a:srgbClr val="8A8A8A"/>
+              <a:rPr lang="en-US" sz="3600" b="1" dirty="0">
+                <a:solidFill>
+                  <a:srgbClr val="BBBBBB"/>
                 </a:solidFill>
                 <a:latin typeface="Arial" pitchFamily="34" charset="0"/>
                 <a:ea typeface="Arial" pitchFamily="34" charset="-122"/>
@@ -2735,7 +2735,7 @@
               </a:rPr>
               <a:t>×2</a:t>
             </a:r>
-            <a:endParaRPr lang="en-US" sz="2600" dirty="0"/>
+            <a:endParaRPr lang="en-US" sz="3600" dirty="0"/>
           </a:p>
         </p:txBody>
       </p:sp>
@@ -2921,7 +2921,7 @@
         </p:nvSpPr>
         <p:spPr>
           <a:xfrm>
-            <a:off x="2786482" y="2755392"/>
+            <a:off x="2885542" y="2755392"/>
             <a:ext cx="0" cy="2971800"/>
           </a:xfrm>
           <a:prstGeom prst="line">
@@ -2944,7 +2944,7 @@
         </p:nvSpPr>
         <p:spPr>
           <a:xfrm>
-            <a:off x="9411614" y="2755392"/>
+            <a:off x="9312554" y="2755392"/>
             <a:ext cx="0" cy="2971800"/>
           </a:xfrm>
           <a:prstGeom prst="line">
@@ -2967,8 +2967,8 @@
         </p:nvSpPr>
         <p:spPr>
           <a:xfrm>
-            <a:off x="9543694" y="4010152"/>
-            <a:ext cx="792480" cy="462280"/>
+            <a:off x="9411614" y="3921252"/>
+            <a:ext cx="1097280" cy="640080"/>
           </a:xfrm>
           <a:prstGeom prst="rect">
             <a:avLst/>
@@ -2984,9 +2984,9 @@
               <a:buNone/>
             </a:pPr>
             <a:r>
-              <a:rPr lang="en-US" sz="2600" b="1" dirty="0">
-                <a:solidFill>
-                  <a:srgbClr val="8A8A8A"/>
+              <a:rPr lang="en-US" sz="3600" b="1" dirty="0">
+                <a:solidFill>
+                  <a:srgbClr val="BBBBBB"/>
                 </a:solidFill>
                 <a:latin typeface="Arial" pitchFamily="34" charset="0"/>
                 <a:ea typeface="Arial" pitchFamily="34" charset="-122"/>
@@ -2994,7 +2994,7 @@
               </a:rPr>
               <a:t>×2</a:t>
             </a:r>
-            <a:endParaRPr lang="en-US" sz="2600" dirty="0"/>
+            <a:endParaRPr lang="en-US" sz="3600" dirty="0"/>
           </a:p>
         </p:txBody>
       </p:sp>
@@ -3200,7 +3200,7 @@
         </p:nvSpPr>
         <p:spPr>
           <a:xfrm>
-            <a:off x="2431517" y="3151632"/>
+            <a:off x="2530577" y="3151632"/>
             <a:ext cx="0" cy="2971800"/>
           </a:xfrm>
           <a:prstGeom prst="line">
@@ -3223,7 +3223,7 @@
         </p:nvSpPr>
         <p:spPr>
           <a:xfrm>
-            <a:off x="9766579" y="3151632"/>
+            <a:off x="9667519" y="3151632"/>
             <a:ext cx="0" cy="2971800"/>
           </a:xfrm>
           <a:prstGeom prst="line">
@@ -3246,8 +3246,8 @@
         </p:nvSpPr>
         <p:spPr>
           <a:xfrm>
-            <a:off x="9898659" y="4406392"/>
-            <a:ext cx="792480" cy="462280"/>
+            <a:off x="9766579" y="4317492"/>
+            <a:ext cx="1097280" cy="640080"/>
           </a:xfrm>
           <a:prstGeom prst="rect">
             <a:avLst/>
@@ -3263,9 +3263,9 @@
               <a:buNone/>
             </a:pPr>
             <a:r>
-              <a:rPr lang="en-US" sz="2600" b="1" dirty="0">
-                <a:solidFill>
-                  <a:srgbClr val="8A8A8A"/>
+              <a:rPr lang="en-US" sz="3600" b="1" dirty="0">
+                <a:solidFill>
+                  <a:srgbClr val="BBBBBB"/>
                 </a:solidFill>
                 <a:latin typeface="Arial" pitchFamily="34" charset="0"/>
                 <a:ea typeface="Arial" pitchFamily="34" charset="-122"/>
@@ -3273,7 +3273,7 @@
               </a:rPr>
               <a:t>×2</a:t>
             </a:r>
-            <a:endParaRPr lang="en-US" sz="2600" dirty="0"/>
+            <a:endParaRPr lang="en-US" sz="3600" dirty="0"/>
           </a:p>
         </p:txBody>
       </p:sp>
@@ -3459,7 +3459,7 @@
         </p:nvSpPr>
         <p:spPr>
           <a:xfrm>
-            <a:off x="2556002" y="2755392"/>
+            <a:off x="2655062" y="2755392"/>
             <a:ext cx="0" cy="2971800"/>
           </a:xfrm>
           <a:prstGeom prst="line">
@@ -3482,7 +3482,7 @@
         </p:nvSpPr>
         <p:spPr>
           <a:xfrm>
-            <a:off x="9642094" y="2755392"/>
+            <a:off x="9543034" y="2755392"/>
             <a:ext cx="0" cy="2971800"/>
           </a:xfrm>
           <a:prstGeom prst="line">
@@ -3505,8 +3505,8 @@
         </p:nvSpPr>
         <p:spPr>
           <a:xfrm>
-            <a:off x="9774174" y="4010152"/>
-            <a:ext cx="792480" cy="462280"/>
+            <a:off x="9642094" y="3921252"/>
+            <a:ext cx="1097280" cy="640080"/>
           </a:xfrm>
           <a:prstGeom prst="rect">
             <a:avLst/>
@@ -3522,9 +3522,9 @@
               <a:buNone/>
             </a:pPr>
             <a:r>
-              <a:rPr lang="en-US" sz="2600" b="1" dirty="0">
-                <a:solidFill>
-                  <a:srgbClr val="8A8A8A"/>
+              <a:rPr lang="en-US" sz="3600" b="1" dirty="0">
+                <a:solidFill>
+                  <a:srgbClr val="BBBBBB"/>
                 </a:solidFill>
                 <a:latin typeface="Arial" pitchFamily="34" charset="0"/>
                 <a:ea typeface="Arial" pitchFamily="34" charset="-122"/>
@@ -3532,7 +3532,7 @@
               </a:rPr>
               <a:t>×2</a:t>
             </a:r>
-            <a:endParaRPr lang="en-US" sz="2600" dirty="0"/>
+            <a:endParaRPr lang="en-US" sz="3600" dirty="0"/>
           </a:p>
         </p:txBody>
       </p:sp>

</xml_diff>